<commit_message>
docs: add merged-map results, refresh SPEC/handoff/decks and result figures
</commit_message>
<xml_diff>
--- a/docs/presentation/xr-splat-decoupled.pptx
+++ b/docs/presentation/xr-splat-decoupled.pptx
@@ -3568,7 +3568,7 @@
       </p:sp>
       <p:pic>
         <p:nvPicPr>
-          <p:cNvPr id="5" name="Picture 4" descr="reloc_demo_still.png"/>
+          <p:cNvPr id="5" name="Picture 4" descr="reloc_demo_still_mcmc2m.png"/>
           <p:cNvPicPr>
             <a:picLocks noChangeAspect="1"/>
           </p:cNvPicPr>
@@ -3583,7 +3583,7 @@
         <p:spPr>
           <a:xfrm>
             <a:off x="6309360" y="2103120"/>
-            <a:ext cx="5486400" cy="1554480"/>
+            <a:ext cx="5486400" cy="1645920"/>
           </a:xfrm>
           <a:prstGeom prst="rect">
             <a:avLst/>
@@ -3798,7 +3798,7 @@
                 </a:solidFill>
                 <a:latin typeface="Malgun Gothic"/>
               </a:rPr>
-              <a:t>•  실사 자산(M2 home): ✅ 23.82, 프레임 유효</a:t>
+              <a:t>•  실사 자산(M2 home, mcmc2m): ✅ PSNR 27.96 / SSIM 0.871 / LPIPS 0.267, 프레임 유효</a:t>
             </a:r>
           </a:p>
           <a:p>
@@ -3872,7 +3872,7 @@
                 </a:solidFill>
                 <a:latin typeface="Malgun Gothic"/>
               </a:rPr>
-              <a:t>남은 한계 &amp; 다음</a:t>
+              <a:t>품질 해소 &amp; 다음</a:t>
             </a:r>
           </a:p>
         </p:txBody>
@@ -3965,40 +3965,51 @@
                 </a:solidFill>
                 <a:latin typeface="Malgun Gothic"/>
               </a:rPr>
-              <a:t>시각 품질은 ‘알아보지만 soft’ — 실사급엔 한 칸 부족</a:t>
+              <a:t>시각 품질 — MCMC strategy로 해소 (mcmc2m 채택)</a:t>
             </a:r>
           </a:p>
           <a:p>
             <a:r>
               <a:rPr sz="1900" b="0">
                 <a:solidFill>
+                  <a:srgbClr val="1E8E3E"/>
+                </a:solidFill>
+                <a:latin typeface="Malgun Gothic"/>
+              </a:rPr>
+              <a:t>•  기존 2M(refine-stop 5k 동결) 23.82 → mcmc2m 27.96 PSNR (+4.1dB, LPIPS 0.39→0.27)</a:t>
+            </a:r>
+          </a:p>
+          <a:p>
+            <a:r>
+              <a:rPr sz="1900" b="0">
+                <a:solidFill>
                   <a:srgbClr val="1A1A1A"/>
                 </a:solidFill>
                 <a:latin typeface="Malgun Gothic"/>
               </a:rPr>
-              <a:t>•  원인: 대형 공간(home 28m) + GPU 12GB가 가우시안 밀도 제한 (메모리 천장)</a:t>
+              <a:t>•  병목은 raw-count가 아니라 배치/정제 — 같은 2M을 계속 정제하니 풀림</a:t>
             </a:r>
           </a:p>
           <a:p>
             <a:r>
               <a:rPr sz="1900" b="0">
                 <a:solidFill>
-                  <a:srgbClr val="1A1A1A"/>
-                </a:solidFill>
-                <a:latin typeface="Malgun Gothic"/>
-              </a:rPr>
-              <a:t>•  다음 후보: scene 타일링(품질) / 잘 찍은 캡처 / XR 뷰어 통합</a:t>
-            </a:r>
-          </a:p>
-          <a:p>
-            <a:r>
-              <a:rPr sz="1900" b="0">
-                <a:solidFill>
-                  <a:srgbClr val="1E8E3E"/>
-                </a:solidFill>
-                <a:latin typeface="Malgun Gothic"/>
-              </a:rPr>
-              <a:t>•  단, 연구 방향(분리가 맞다)은 결론남</a:t>
+                  <a:srgbClr val="2E86C1"/>
+                </a:solidFill>
+                <a:latin typeface="Malgun Gothic"/>
+              </a:rPr>
+              <a:t>•  scene 타일링: 통제 비교(2M≈3M)로 불필요 확인 → 선반행</a:t>
+            </a:r>
+          </a:p>
+          <a:p>
+            <a:r>
+              <a:rPr sz="2200" b="1">
+                <a:solidFill>
+                  <a:srgbClr val="121B2E"/>
+                </a:solidFill>
+                <a:latin typeface="Malgun Gothic"/>
+              </a:rPr>
+              <a:t>다음: ad-server 복귀 (motion 18개 smoke test)</a:t>
             </a:r>
           </a:p>
         </p:txBody>

</xml_diff>